<commit_message>
corrected Jenkins Agent 50000 by removing it as it is not needed
</commit_message>
<xml_diff>
--- a/3-Jenkins/Lab2.pptx
+++ b/3-Jenkins/Lab2.pptx
@@ -273,7 +273,7 @@
           <a:p>
             <a:fld id="{DEE6B2CF-0566-43C4-B778-CF73F2BEE112}" type="datetimeFigureOut">
               <a:rPr lang="en-GB" smtClean="0"/>
-              <a:t>13/09/2024</a:t>
+              <a:t>18/06/2026</a:t>
             </a:fld>
             <a:endParaRPr lang="en-GB"/>
           </a:p>
@@ -473,7 +473,7 @@
           <a:p>
             <a:fld id="{DEE6B2CF-0566-43C4-B778-CF73F2BEE112}" type="datetimeFigureOut">
               <a:rPr lang="en-GB" smtClean="0"/>
-              <a:t>13/09/2024</a:t>
+              <a:t>18/06/2026</a:t>
             </a:fld>
             <a:endParaRPr lang="en-GB"/>
           </a:p>
@@ -683,7 +683,7 @@
           <a:p>
             <a:fld id="{DEE6B2CF-0566-43C4-B778-CF73F2BEE112}" type="datetimeFigureOut">
               <a:rPr lang="en-GB" smtClean="0"/>
-              <a:t>13/09/2024</a:t>
+              <a:t>18/06/2026</a:t>
             </a:fld>
             <a:endParaRPr lang="en-GB"/>
           </a:p>
@@ -883,7 +883,7 @@
           <a:p>
             <a:fld id="{DEE6B2CF-0566-43C4-B778-CF73F2BEE112}" type="datetimeFigureOut">
               <a:rPr lang="en-GB" smtClean="0"/>
-              <a:t>13/09/2024</a:t>
+              <a:t>18/06/2026</a:t>
             </a:fld>
             <a:endParaRPr lang="en-GB"/>
           </a:p>
@@ -1159,7 +1159,7 @@
           <a:p>
             <a:fld id="{DEE6B2CF-0566-43C4-B778-CF73F2BEE112}" type="datetimeFigureOut">
               <a:rPr lang="en-GB" smtClean="0"/>
-              <a:t>13/09/2024</a:t>
+              <a:t>18/06/2026</a:t>
             </a:fld>
             <a:endParaRPr lang="en-GB"/>
           </a:p>
@@ -1427,7 +1427,7 @@
           <a:p>
             <a:fld id="{DEE6B2CF-0566-43C4-B778-CF73F2BEE112}" type="datetimeFigureOut">
               <a:rPr lang="en-GB" smtClean="0"/>
-              <a:t>13/09/2024</a:t>
+              <a:t>18/06/2026</a:t>
             </a:fld>
             <a:endParaRPr lang="en-GB"/>
           </a:p>
@@ -1842,7 +1842,7 @@
           <a:p>
             <a:fld id="{DEE6B2CF-0566-43C4-B778-CF73F2BEE112}" type="datetimeFigureOut">
               <a:rPr lang="en-GB" smtClean="0"/>
-              <a:t>13/09/2024</a:t>
+              <a:t>18/06/2026</a:t>
             </a:fld>
             <a:endParaRPr lang="en-GB"/>
           </a:p>
@@ -1984,7 +1984,7 @@
           <a:p>
             <a:fld id="{DEE6B2CF-0566-43C4-B778-CF73F2BEE112}" type="datetimeFigureOut">
               <a:rPr lang="en-GB" smtClean="0"/>
-              <a:t>13/09/2024</a:t>
+              <a:t>18/06/2026</a:t>
             </a:fld>
             <a:endParaRPr lang="en-GB"/>
           </a:p>
@@ -2097,7 +2097,7 @@
           <a:p>
             <a:fld id="{DEE6B2CF-0566-43C4-B778-CF73F2BEE112}" type="datetimeFigureOut">
               <a:rPr lang="en-GB" smtClean="0"/>
-              <a:t>13/09/2024</a:t>
+              <a:t>18/06/2026</a:t>
             </a:fld>
             <a:endParaRPr lang="en-GB"/>
           </a:p>
@@ -2410,7 +2410,7 @@
           <a:p>
             <a:fld id="{DEE6B2CF-0566-43C4-B778-CF73F2BEE112}" type="datetimeFigureOut">
               <a:rPr lang="en-GB" smtClean="0"/>
-              <a:t>13/09/2024</a:t>
+              <a:t>18/06/2026</a:t>
             </a:fld>
             <a:endParaRPr lang="en-GB"/>
           </a:p>
@@ -2699,7 +2699,7 @@
           <a:p>
             <a:fld id="{DEE6B2CF-0566-43C4-B778-CF73F2BEE112}" type="datetimeFigureOut">
               <a:rPr lang="en-GB" smtClean="0"/>
-              <a:t>13/09/2024</a:t>
+              <a:t>18/06/2026</a:t>
             </a:fld>
             <a:endParaRPr lang="en-GB"/>
           </a:p>
@@ -2942,7 +2942,7 @@
           <a:p>
             <a:fld id="{DEE6B2CF-0566-43C4-B778-CF73F2BEE112}" type="datetimeFigureOut">
               <a:rPr lang="en-GB" smtClean="0"/>
-              <a:t>13/09/2024</a:t>
+              <a:t>18/06/2026</a:t>
             </a:fld>
             <a:endParaRPr lang="en-GB"/>
           </a:p>
@@ -5955,13 +5955,13 @@
               <p:nvPr/>
             </p:nvPicPr>
             <p:blipFill>
-              <a:blip r:embed="rId6">
+              <a:blip>
                 <a:extLst>
                   <a:ext uri="{28A0092B-C50C-407E-A947-70E740481C1C}">
                     <a14:useLocalDpi xmlns:a14="http://schemas.microsoft.com/office/drawing/2010/main" val="0"/>
                   </a:ext>
                   <a:ext uri="{96DAC541-7B7A-43D3-8B79-37D633B846F1}">
-                    <asvg:svgBlip xmlns:asvg="http://schemas.microsoft.com/office/drawing/2016/SVG/main" r:embed="rId7"/>
+                    <asvg:svgBlip xmlns:asvg="http://schemas.microsoft.com/office/drawing/2016/SVG/main" r:embed="rId6"/>
                   </a:ext>
                 </a:extLst>
               </a:blip>
@@ -5994,13 +5994,13 @@
               <p:nvPr/>
             </p:nvPicPr>
             <p:blipFill>
-              <a:blip r:embed="rId8">
+              <a:blip>
                 <a:extLst>
                   <a:ext uri="{28A0092B-C50C-407E-A947-70E740481C1C}">
                     <a14:useLocalDpi xmlns:a14="http://schemas.microsoft.com/office/drawing/2010/main" val="0"/>
                   </a:ext>
                   <a:ext uri="{96DAC541-7B7A-43D3-8B79-37D633B846F1}">
-                    <asvg:svgBlip xmlns:asvg="http://schemas.microsoft.com/office/drawing/2016/SVG/main" r:embed="rId9"/>
+                    <asvg:svgBlip xmlns:asvg="http://schemas.microsoft.com/office/drawing/2016/SVG/main" r:embed="rId7"/>
                   </a:ext>
                 </a:extLst>
               </a:blip>
@@ -6995,7 +6995,7 @@
                 <a:effectLst/>
                 <a:latin typeface="Consolas" panose="020B0609020204030204" pitchFamily="49" charset="0"/>
               </a:rPr>
-              <a:t>docker run -p 8080:8080 -p 50000:50000 -v </a:t>
+              <a:t>docker run -p 8080:8080 -v </a:t>
             </a:r>
             <a:r>
               <a:rPr lang="en-GB" sz="1600" b="1" i="0" dirty="0" err="1">
@@ -7055,7 +7055,17 @@
                 <a:effectLst/>
                 <a:latin typeface="Consolas" panose="020B0609020204030204" pitchFamily="49" charset="0"/>
               </a:rPr>
-              <a:t>/jenkins:lts-jdk11</a:t>
+              <a:t>/</a:t>
+            </a:r>
+            <a:r>
+              <a:rPr lang="en-GB" sz="1600" b="1" i="0" dirty="0" err="1">
+                <a:solidFill>
+                  <a:srgbClr val="C5C8C6"/>
+                </a:solidFill>
+                <a:effectLst/>
+                <a:latin typeface="Consolas" panose="020B0609020204030204" pitchFamily="49" charset="0"/>
+              </a:rPr>
+              <a:t>jenkins:lts</a:t>
             </a:r>
             <a:endParaRPr lang="en-GB" sz="1600" b="1" dirty="0"/>
           </a:p>

</xml_diff>